<commit_message>
WIP: real-data HIMSHAKTI console and data corrections (local only, not pushed)
Co-Authored-By: Claude Opus 5.5 <noreply@anthropic.com>
</commit_message>
<xml_diff>
--- a/engine/submission/SIH26061_Idea_Presentation.pptx
+++ b/engine/submission/SIH26061_Idea_Presentation.pptx
@@ -6085,7 +6085,7 @@
                 </a:solidFill>
                 <a:latin typeface="Calibri"/>
               </a:rPr>
-              <a:t>•  Outer level: Monte Carlo allocator sets a daily litre allowance that holds P(critical load served to the ship) ≥ 99%</a:t>
+              <a:t>•  Outer level: Monte Carlo allocator over past winters sets a daily litre allowance, targeting critical load served until the ship in 99% of winters</a:t>
             </a:r>
           </a:p>
           <a:p>
@@ -6789,7 +6789,7 @@
                 </a:solidFill>
                 <a:latin typeface="Calibri"/>
               </a:rPr>
-              <a:t>•  Offline single-file HTML console (Plotly inlined) · Modbus + MQTT setpoint interface</a:t>
+              <a:t>•  Web console: React · Emotion · Motion, built for offline use · Modbus + MQTT setpoint interface</a:t>
             </a:r>
           </a:p>
           <a:p>
@@ -6826,7 +6826,7 @@
                 </a:solidFill>
                 <a:latin typeface="Calibri"/>
               </a:rPr>
-              <a:t>•  Closed-loop simulation of a 210-day season (2023-02-01 to 2023-08-30), re-optimised on a 36 h rolling horizon</a:t>
+              <a:t>•  Closed-loop simulation scored over 208 days (2023-02-01 to 2023-08-30, after a 48 h warm-up), re-optimised on a 36 h rolling horizon</a:t>
             </a:r>
           </a:p>
           <a:p>
@@ -7478,7 +7478,7 @@
                 </a:solidFill>
                 <a:latin typeface="Calibri"/>
               </a:rPr>
-              <a:t>•  Load synthesised bottom-up from physics, never drawn; calibrated to published Antarctic station fuel-demand shapes</a:t>
+              <a:t>•  Load modelled bottom-up from physics, never drawn; checked against published Antarctic station fuel-demand shapes</a:t>
             </a:r>
           </a:p>
           <a:p>

</xml_diff>